<commit_message>
docs: fold the three rerun benches into the summary table, correct the score
- burro6, kit-fox-u5-2 and thorney-island-08 now sit in the main table with
  their measured SPMs and RhoReactingBuoyantFoam as the solver
- the LNG cohort goes 8 -> 9; Kit Fox and Thorney Island leave the Gaussian
  out-of-scope group for a new OpenFOAM dense-gas group
- headline corrected from 18 PASS / 31 to 17 PASS / 31. must-trial-11 was
  counted in both its own group and the FluidX3D baselines, inflating both
  columns by one; the summary table's placeholder row existed to pad its
  length to the inflated total. Counting rows gives 17 PASS, 14 FAIL, 31
  benches. No bench changed result, only the arithmetic
- group table gains a Total row so the sum is checkable
- validation deck rebuilt with the same figures

Co-Authored-By: Claude Opus 5 <noreply@anthropic.com>
</commit_message>
<xml_diff>
--- a/docs/DisperSim3D-Validacao.pptx
+++ b/docs/DisperSim3D-Validacao.pptx
@@ -8060,7 +8060,7 @@
                 </a:solidFill>
                 <a:latin typeface="Bahnschrift"/>
               </a:rPr>
-              <a:t>Dispersão: 18 aprovados em 31</a:t>
+              <a:t>Dispersão: 17 aprovados em 31</a:t>
             </a:r>
           </a:p>
         </p:txBody>
@@ -8102,7 +8102,7 @@
                 </a:solidFill>
                 <a:latin typeface="Segoe UI"/>
               </a:rPr>
-              <a:t>Rodada registrada em 16/05/2026  ·  o número só é legível depois de separar as treze diferenças por causa</a:t>
+              <a:t>Rodadas de 16/05/2026 e 31/08/2026  ·  o número só é legível depois de separar as catorze diferenças por causa</a:t>
             </a:r>
           </a:p>
         </p:txBody>
@@ -8161,7 +8161,7 @@
         </p:nvGraphicFramePr>
         <p:xfrm>
           <a:off x="777240" y="2231136"/>
-          <a:ext cx="10634470" cy="2871216"/>
+          <a:ext cx="10634470" cy="3191256"/>
         </p:xfrm>
         <a:graphic>
           <a:graphicData uri="http://schemas.openxmlformats.org/drawingml/2006/table">
@@ -8585,7 +8585,7 @@
                           </a:solidFill>
                           <a:latin typeface="Consolas"/>
                         </a:rPr>
-                        <a:t>8</a:t>
+                        <a:t>9</a:t>
                       </a:r>
                     </a:p>
                   </a:txBody>
@@ -9013,7 +9013,7 @@
                           </a:solidFill>
                           <a:latin typeface="Consolas"/>
                         </a:rPr>
-                        <a:t>3</a:t>
+                        <a:t>2</a:t>
                       </a:r>
                     </a:p>
                   </a:txBody>
@@ -9041,7 +9041,7 @@
                           </a:solidFill>
                           <a:latin typeface="Consolas"/>
                         </a:rPr>
-                        <a:t>5</a:t>
+                        <a:t>4</a:t>
                       </a:r>
                     </a:p>
                   </a:txBody>
@@ -9070,6 +9070,120 @@
                           <a:latin typeface="Segoe UI"/>
                         </a:rPr>
                         <a:t>Linhas de base de regressão e Witlox 2014</a:t>
+                      </a:r>
+                    </a:p>
+                  </a:txBody>
+                  <a:tcPr marL="82296" marR="82296" marT="27432" marB="27432" anchor="ctr">
+                    <a:solidFill>
+                      <a:srgbClr val="FFFFFF"/>
+                    </a:solidFill>
+                    <a:lnB w="9525" cap="flat" cmpd="sng" algn="ctr">
+                      <a:solidFill>
+                        <a:srgbClr val="DDE3E1"/>
+                      </a:solidFill>
+                    </a:lnB>
+                  </a:tcPr>
+                </a:tc>
+              </a:tr>
+              <a:tr h="320040">
+                <a:tc>
+                  <a:txBody>
+                    <a:bodyPr wrap="square"/>
+                    <a:lstStyle/>
+                    <a:p>
+                      <a:pPr algn="l"/>
+                      <a:r>
+                        <a:rPr sz="1050" b="0">
+                          <a:solidFill>
+                            <a:srgbClr val="111A1D"/>
+                          </a:solidFill>
+                          <a:latin typeface="Segoe UI"/>
+                        </a:rPr>
+                        <a:t>Gás denso no OpenFOAM: Thorney Island, Kit Fox</a:t>
+                      </a:r>
+                    </a:p>
+                  </a:txBody>
+                  <a:tcPr marL="82296" marR="82296" marT="27432" marB="27432" anchor="ctr">
+                    <a:solidFill>
+                      <a:srgbClr val="FFFFFF"/>
+                    </a:solidFill>
+                    <a:lnB w="9525" cap="flat" cmpd="sng" algn="ctr">
+                      <a:solidFill>
+                        <a:srgbClr val="DDE3E1"/>
+                      </a:solidFill>
+                    </a:lnB>
+                  </a:tcPr>
+                </a:tc>
+                <a:tc>
+                  <a:txBody>
+                    <a:bodyPr wrap="square"/>
+                    <a:lstStyle/>
+                    <a:p>
+                      <a:pPr algn="r"/>
+                      <a:r>
+                        <a:rPr sz="1050" b="1">
+                          <a:solidFill>
+                            <a:srgbClr val="9A6A0C"/>
+                          </a:solidFill>
+                          <a:latin typeface="Consolas"/>
+                        </a:rPr>
+                        <a:t>0</a:t>
+                      </a:r>
+                    </a:p>
+                  </a:txBody>
+                  <a:tcPr marL="82296" marR="82296" marT="27432" marB="27432" anchor="ctr">
+                    <a:solidFill>
+                      <a:srgbClr val="FFFFFF"/>
+                    </a:solidFill>
+                    <a:lnB w="9525" cap="flat" cmpd="sng" algn="ctr">
+                      <a:solidFill>
+                        <a:srgbClr val="DDE3E1"/>
+                      </a:solidFill>
+                    </a:lnB>
+                  </a:tcPr>
+                </a:tc>
+                <a:tc>
+                  <a:txBody>
+                    <a:bodyPr wrap="square"/>
+                    <a:lstStyle/>
+                    <a:p>
+                      <a:pPr algn="r"/>
+                      <a:r>
+                        <a:rPr sz="1050" b="0">
+                          <a:solidFill>
+                            <a:srgbClr val="111A1D"/>
+                          </a:solidFill>
+                          <a:latin typeface="Consolas"/>
+                        </a:rPr>
+                        <a:t>2</a:t>
+                      </a:r>
+                    </a:p>
+                  </a:txBody>
+                  <a:tcPr marL="82296" marR="82296" marT="27432" marB="27432" anchor="ctr">
+                    <a:solidFill>
+                      <a:srgbClr val="FFFFFF"/>
+                    </a:solidFill>
+                    <a:lnB w="9525" cap="flat" cmpd="sng" algn="ctr">
+                      <a:solidFill>
+                        <a:srgbClr val="DDE3E1"/>
+                      </a:solidFill>
+                    </a:lnB>
+                  </a:tcPr>
+                </a:tc>
+                <a:tc>
+                  <a:txBody>
+                    <a:bodyPr wrap="square"/>
+                    <a:lstStyle/>
+                    <a:p>
+                      <a:pPr algn="l"/>
+                      <a:r>
+                        <a:rPr sz="1050" b="0">
+                          <a:solidFill>
+                            <a:srgbClr val="111A1D"/>
+                          </a:solidFill>
+                          <a:latin typeface="Segoe UI"/>
+                        </a:rPr>
+                        <a:t>Coortes FLACS Hansen 2010 e Hanna 2004</a:t>
                       </a:r>
                     </a:p>
                   </a:txBody>
@@ -9155,7 +9269,7 @@
                           </a:solidFill>
                           <a:latin typeface="Consolas"/>
                         </a:rPr>
-                        <a:t>6</a:t>
+                        <a:t>4</a:t>
                       </a:r>
                     </a:p>
                   </a:txBody>
@@ -17999,7 +18113,7 @@
                 </a:solidFill>
                 <a:latin typeface="Bahnschrift"/>
               </a:rPr>
-              <a:t>18</a:t>
+              <a:t>17</a:t>
             </a:r>
             <a:r>
               <a:rPr sz="1700" b="1">
@@ -18050,7 +18164,7 @@
                 </a:solidFill>
                 <a:latin typeface="Segoe UI"/>
               </a:rPr>
-              <a:t>Contra o desempenho publicado do FLACS e do PHAST nos mesmos ensaios. Seis das treze diferenças são fronteiras de escopo declaradas.</a:t>
+              <a:t>Contra o desempenho publicado do FLACS e do PHAST nos mesmos ensaios. Quatro das catorze diferenças são fronteiras de escopo declaradas.</a:t>
             </a:r>
           </a:p>
         </p:txBody>

</xml_diff>

<commit_message>
docs: re-measure the LNG cohort and close out the Sct finding
All nine LNG benches rerun on 2026-09-02 with the cryogenic preset no longer
dispatching the patched Sct solver. Every one reproduces the figures recorded
on 2026-05-16, so the cohort is reproducible from a default checkout again.

- burro6 turns FAIL into PASS (MG 1.14). It had been recorded as failing on
  "the Sct limitation"; it was failing because of the patched solver and that
  attribution was wrong
- LNG cohort 5/9 -> 6/9, headline 17 -> 18 PASS of 31
- the finding section now records how it was settled: these benches are
  scored against published FLACS numbers, so agreement with the paper decides
  it, and the stock solver is closer on every one
- two leftovers noted: Sct = 0.15 is still written into cryogenic cases and
  is inert there, and the three remaining failures all under-predict the far
  arcs
- deck rebuilt

Co-Authored-By: Claude Opus 5 <noreply@anthropic.com>
</commit_message>
<xml_diff>
--- a/docs/DisperSim3D-Validacao.pptx
+++ b/docs/DisperSim3D-Validacao.pptx
@@ -8060,7 +8060,7 @@
                 </a:solidFill>
                 <a:latin typeface="Bahnschrift"/>
               </a:rPr>
-              <a:t>Dispersão: 17 aprovados em 31</a:t>
+              <a:t>Dispersão: 18 aprovados em 31</a:t>
             </a:r>
           </a:p>
         </p:txBody>
@@ -8102,7 +8102,7 @@
                 </a:solidFill>
                 <a:latin typeface="Segoe UI"/>
               </a:rPr>
-              <a:t>Rodadas de 16/05/2026 e 31/08/2026  ·  o número só é legível depois de separar as catorze diferenças por causa</a:t>
+              <a:t>Rodadas de 16/05/2026 e 31/08/2026  ·  o número só é legível depois de separar as treze diferenças por causa</a:t>
             </a:r>
           </a:p>
         </p:txBody>
@@ -8557,7 +8557,7 @@
                           </a:solidFill>
                           <a:latin typeface="Consolas"/>
                         </a:rPr>
-                        <a:t>5</a:t>
+                        <a:t>6</a:t>
                       </a:r>
                     </a:p>
                   </a:txBody>
@@ -18113,7 +18113,7 @@
                 </a:solidFill>
                 <a:latin typeface="Bahnschrift"/>
               </a:rPr>
-              <a:t>17</a:t>
+              <a:t>18</a:t>
             </a:r>
             <a:r>
               <a:rPr sz="1700" b="1">
@@ -18164,7 +18164,7 @@
                 </a:solidFill>
                 <a:latin typeface="Segoe UI"/>
               </a:rPr>
-              <a:t>Contra o desempenho publicado do FLACS e do PHAST nos mesmos ensaios. Quatro das catorze diferenças são fronteiras de escopo declaradas.</a:t>
+              <a:t>Contra o desempenho publicado do FLACS e do PHAST nos mesmos ensaios. Quatro das treze diferenças são fronteiras de escopo declaradas.</a:t>
             </a:r>
           </a:p>
         </p:txBody>

</xml_diff>

<commit_message>
docs: report the benchmark score by evidence class
The headline added a self-consistency check to a field trial and called the
sum a score. It now leads with 12 of 23 against published experiments and
lists the rest separately, since a pass in each class buys something
different.

- new Data confidence section: the five levels, how many benches hold each,
  and why an unverified bench is never counted in either direction
- headline replaced with the per-class table; counted total 18 of 30, plus
  1 not counted, of 31 benches
- hydrogen-jet-schefer's summary row reads "not counted" rather than FAIL
- group table reconciled to the same denominator, and the note now records
  all three moves the passing count has made, none of them a model change
- deck leads with 12 / 23 and its cohort slide gains the counted total

Co-Authored-By: Claude Opus 5 <noreply@anthropic.com>
</commit_message>
<xml_diff>
--- a/docs/DisperSim3D-Validacao.pptx
+++ b/docs/DisperSim3D-Validacao.pptx
@@ -8161,7 +8161,7 @@
         </p:nvGraphicFramePr>
         <p:xfrm>
           <a:off x="777240" y="2231136"/>
-          <a:ext cx="10634470" cy="3191256"/>
+          <a:ext cx="10634470" cy="3328416"/>
         </p:xfrm>
         <a:graphic>
           <a:graphicData uri="http://schemas.openxmlformats.org/drawingml/2006/table">
@@ -8287,7 +8287,7 @@
                   </a:tcPr>
                 </a:tc>
               </a:tr>
-              <a:tr h="320040">
+              <a:tr h="301752">
                 <a:tc>
                   <a:txBody>
                     <a:bodyPr wrap="square"/>
@@ -8401,7 +8401,7 @@
                   </a:tcPr>
                 </a:tc>
               </a:tr>
-              <a:tr h="320040">
+              <a:tr h="301752">
                 <a:tc>
                   <a:txBody>
                     <a:bodyPr wrap="square"/>
@@ -8515,7 +8515,7 @@
                   </a:tcPr>
                 </a:tc>
               </a:tr>
-              <a:tr h="320040">
+              <a:tr h="301752">
                 <a:tc>
                   <a:txBody>
                     <a:bodyPr wrap="square"/>
@@ -8629,7 +8629,7 @@
                   </a:tcPr>
                 </a:tc>
               </a:tr>
-              <a:tr h="320040">
+              <a:tr h="301752">
                 <a:tc>
                   <a:txBody>
                     <a:bodyPr wrap="square"/>
@@ -8743,7 +8743,7 @@
                   </a:tcPr>
                 </a:tc>
               </a:tr>
-              <a:tr h="320040">
+              <a:tr h="301752">
                 <a:tc>
                   <a:txBody>
                     <a:bodyPr wrap="square"/>
@@ -8857,7 +8857,7 @@
                   </a:tcPr>
                 </a:tc>
               </a:tr>
-              <a:tr h="320040">
+              <a:tr h="301752">
                 <a:tc>
                   <a:txBody>
                     <a:bodyPr wrap="square"/>
@@ -8971,7 +8971,7 @@
                   </a:tcPr>
                 </a:tc>
               </a:tr>
-              <a:tr h="320040">
+              <a:tr h="301752">
                 <a:tc>
                   <a:txBody>
                     <a:bodyPr wrap="square"/>
@@ -9085,7 +9085,7 @@
                   </a:tcPr>
                 </a:tc>
               </a:tr>
-              <a:tr h="320040">
+              <a:tr h="301752">
                 <a:tc>
                   <a:txBody>
                     <a:bodyPr wrap="square"/>
@@ -9199,7 +9199,7 @@
                   </a:tcPr>
                 </a:tc>
               </a:tr>
-              <a:tr h="320040">
+              <a:tr h="301752">
                 <a:tc>
                   <a:txBody>
                     <a:bodyPr wrap="square"/>
@@ -9313,6 +9313,120 @@
                   </a:tcPr>
                 </a:tc>
               </a:tr>
+              <a:tr h="301752">
+                <a:tc>
+                  <a:txBody>
+                    <a:bodyPr wrap="square"/>
+                    <a:lstStyle/>
+                    <a:p>
+                      <a:pPr algn="l"/>
+                      <a:r>
+                        <a:rPr sz="1050" b="1">
+                          <a:solidFill>
+                            <a:srgbClr val="111A1D"/>
+                          </a:solidFill>
+                          <a:latin typeface="Segoe UI"/>
+                        </a:rPr>
+                        <a:t>Total contabilizado</a:t>
+                      </a:r>
+                    </a:p>
+                  </a:txBody>
+                  <a:tcPr marL="82296" marR="82296" marT="27432" marB="27432" anchor="ctr">
+                    <a:solidFill>
+                      <a:srgbClr val="FFFFFF"/>
+                    </a:solidFill>
+                    <a:lnB w="9525" cap="flat" cmpd="sng" algn="ctr">
+                      <a:solidFill>
+                        <a:srgbClr val="DDE3E1"/>
+                      </a:solidFill>
+                    </a:lnB>
+                  </a:tcPr>
+                </a:tc>
+                <a:tc>
+                  <a:txBody>
+                    <a:bodyPr wrap="square"/>
+                    <a:lstStyle/>
+                    <a:p>
+                      <a:pPr algn="r"/>
+                      <a:r>
+                        <a:rPr sz="1050" b="1">
+                          <a:solidFill>
+                            <a:srgbClr val="111A1D"/>
+                          </a:solidFill>
+                          <a:latin typeface="Consolas"/>
+                        </a:rPr>
+                        <a:t>18</a:t>
+                      </a:r>
+                    </a:p>
+                  </a:txBody>
+                  <a:tcPr marL="82296" marR="82296" marT="27432" marB="27432" anchor="ctr">
+                    <a:solidFill>
+                      <a:srgbClr val="FFFFFF"/>
+                    </a:solidFill>
+                    <a:lnB w="9525" cap="flat" cmpd="sng" algn="ctr">
+                      <a:solidFill>
+                        <a:srgbClr val="DDE3E1"/>
+                      </a:solidFill>
+                    </a:lnB>
+                  </a:tcPr>
+                </a:tc>
+                <a:tc>
+                  <a:txBody>
+                    <a:bodyPr wrap="square"/>
+                    <a:lstStyle/>
+                    <a:p>
+                      <a:pPr algn="r"/>
+                      <a:r>
+                        <a:rPr sz="1050" b="1">
+                          <a:solidFill>
+                            <a:srgbClr val="111A1D"/>
+                          </a:solidFill>
+                          <a:latin typeface="Consolas"/>
+                        </a:rPr>
+                        <a:t>30</a:t>
+                      </a:r>
+                    </a:p>
+                  </a:txBody>
+                  <a:tcPr marL="82296" marR="82296" marT="27432" marB="27432" anchor="ctr">
+                    <a:solidFill>
+                      <a:srgbClr val="FFFFFF"/>
+                    </a:solidFill>
+                    <a:lnB w="9525" cap="flat" cmpd="sng" algn="ctr">
+                      <a:solidFill>
+                        <a:srgbClr val="DDE3E1"/>
+                      </a:solidFill>
+                    </a:lnB>
+                  </a:tcPr>
+                </a:tc>
+                <a:tc>
+                  <a:txBody>
+                    <a:bodyPr wrap="square"/>
+                    <a:lstStyle/>
+                    <a:p>
+                      <a:pPr algn="l"/>
+                      <a:r>
+                        <a:rPr sz="1050" b="0">
+                          <a:solidFill>
+                            <a:srgbClr val="5B6A6E"/>
+                          </a:solidFill>
+                          <a:latin typeface="Segoe UI"/>
+                        </a:rPr>
+                        <a:t>Mais 1 não contabilizado, dado nunca conferido</a:t>
+                      </a:r>
+                    </a:p>
+                  </a:txBody>
+                  <a:tcPr marL="82296" marR="82296" marT="27432" marB="27432" anchor="ctr">
+                    <a:solidFill>
+                      <a:srgbClr val="FFFFFF"/>
+                    </a:solidFill>
+                    <a:lnB w="9525" cap="flat" cmpd="sng" algn="ctr">
+                      <a:solidFill>
+                        <a:srgbClr val="DDE3E1"/>
+                      </a:solidFill>
+                    </a:lnB>
+                  </a:tcPr>
+                </a:tc>
+              </a:tr>
             </a:tbl>
           </a:graphicData>
         </a:graphic>
@@ -9378,7 +9492,7 @@
             <a:avLst/>
           </a:prstGeom>
           <a:solidFill>
-            <a:srgbClr val="2C7A5A"/>
+            <a:srgbClr val="C25B00"/>
           </a:solidFill>
           <a:ln>
             <a:noFill/>
@@ -9440,11 +9554,11 @@
             <a:r>
               <a:rPr sz="1000" b="0" spc="140">
                 <a:solidFill>
-                  <a:srgbClr val="2C7A5A"/>
+                  <a:srgbClr val="C25B00"/>
                 </a:solidFill>
                 <a:latin typeface="Consolas"/>
               </a:rPr>
-              <a:t>ONDE O DISPERSIM É MELHOR QUE A REFERÊNCIA</a:t>
+              <a:t>O QUE CADA APROVAÇÃO VALE</a:t>
             </a:r>
           </a:p>
         </p:txBody>
@@ -9486,7 +9600,7 @@
                 </a:solidFill>
                 <a:latin typeface="Segoe UI"/>
               </a:rPr>
-              <a:t>O desempenho publicado do FLACS em Falcon com barreira de vapor é FAC2 = 0,00, MG = 5,56, VG = 23,65. O DisperSim chega a FAC2 = 1,00 em Falcon 3 e Falcon 4, com MG de 1,40 e 1,26.</a:t>
+              <a:t>12 de 23 medem contra experimento publicado. Outros 5 comparam o motor com a saída anterior dele mesmo e 2 com a própria solução analítica: pegam deriva, não dizem nada sobre física. 1 não é contabilizado porque seus valores de sensor nunca foram conferidos contra fonte.</a:t>
             </a:r>
           </a:p>
         </p:txBody>
@@ -18113,7 +18227,7 @@
                 </a:solidFill>
                 <a:latin typeface="Bahnschrift"/>
               </a:rPr>
-              <a:t>18</a:t>
+              <a:t>12</a:t>
             </a:r>
             <a:r>
               <a:rPr sz="1700" b="1">
@@ -18122,7 +18236,7 @@
                 </a:solidFill>
                 <a:latin typeface="Bahnschrift"/>
               </a:rPr>
-              <a:t> / 31</a:t>
+              <a:t> / 23</a:t>
             </a:r>
           </a:p>
         </p:txBody>
@@ -18164,7 +18278,7 @@
                 </a:solidFill>
                 <a:latin typeface="Segoe UI"/>
               </a:rPr>
-              <a:t>Contra o desempenho publicado do FLACS e do PHAST nos mesmos ensaios. Quatro das treze diferenças são fronteiras de escopo declaradas.</a:t>
+              <a:t>Contra experimento publicado. Outros 7 benchmarks medem o motor contra ele mesmo e 1 não é contabilizado, somando 18 de 30.</a:t>
             </a:r>
           </a:p>
         </p:txBody>

</xml_diff>